<commit_message>
feat: r60 — presentation: eBPF-with-Aya 201 deck (~3h) + bullet sub-line fix
- presentation/deck-201.js — 44 slides, thick speaker notes on every one
  (parity checked). Standalone with a fast fundamentals recap, then: verifier
  + CO-RE/BTF, maps in depth (pinning/ringbuf), advanced tracing (container
  uprobes, split-debug/eu-unstrip, USDT-vs-.symtab), fentry/kfuncs + the aya
  kfunc limit, networking depth (XDP modes/state), security/LSM enforcement,
  the frontier (struct_ops/sched_ext/timers/user_ringbuf/iterators), an honest
  aya-vs-C boundary, and production observability (three signals, trace
  correlation). Output: presentation/ebpf-aya-201-r01.0.pptx.
- presentation/diagrams.py — +7 advanced scenes (btf-core, container-uprobe,
  lsm-decision, frontier, aya-c-boundary, correlation, verifier-detail).
- deck-helpers.js addBullets: render the {text, sub} `sub` field as a muted
  indented continuation line (it was being dropped on-slide); rebuilds 101 too.
</commit_message>
<xml_diff>
--- a/presentation/ebpf-aya-101-r01.0.pptx
+++ b/presentation/ebpf-aya-101-r01.0.pptx
@@ -5629,15 +5629,15 @@
           <a:bodyPr wrap="square" rtlCol="0" anchor="t"/>
           <a:lstStyle/>
           <a:p>
-            <a:pPr algn="l" lvl="1" marL="203200" indent="-101600">
+            <a:pPr algn="l" marL="342900" indent="-342900">
               <a:lnSpc>
                 <a:spcPct val="115000"/>
               </a:lnSpc>
               <a:spcAft>
-                <a:spcPts val="400"/>
+                <a:spcPts val="200"/>
               </a:spcAft>
               <a:buSzPct val="100000"/>
-              <a:buChar char="◦"/>
+              <a:buChar char="●"/>
             </a:pPr>
             <a:r>
               <a:rPr lang="en-US" sz="1600" dirty="0">
@@ -5653,39 +5653,38 @@
             <a:endParaRPr lang="en-US" sz="1600" dirty="0"/>
           </a:p>
           <a:p>
-            <a:pPr algn="l" lvl="1" marL="203200" indent="-101600">
+            <a:pPr algn="l" lvl="1" indent="0" marL="0">
               <a:lnSpc>
                 <a:spcPct val="115000"/>
               </a:lnSpc>
               <a:spcAft>
-                <a:spcPts val="400"/>
+                <a:spcPts val="600"/>
               </a:spcAft>
-              <a:buSzPct val="100000"/>
-              <a:buChar char="◦"/>
-            </a:pPr>
-            <a:r>
-              <a:rPr lang="en-US" sz="1600" dirty="0">
-                <a:solidFill>
-                  <a:srgbClr val="242424"/>
+              <a:buNone/>
+            </a:pPr>
+            <a:r>
+              <a:rPr lang="en-US" sz="1300" dirty="0">
+                <a:solidFill>
+                  <a:srgbClr val="5A5A5A"/>
                 </a:solidFill>
                 <a:latin typeface="Red Hat Text" pitchFamily="34" charset="0"/>
                 <a:ea typeface="Red Hat Text" pitchFamily="34" charset="-122"/>
                 <a:cs typeface="Red Hat Text" pitchFamily="34" charset="-120"/>
               </a:rPr>
-              <a:t>bpf-linker</a:t>
+              <a:t>— the BPF target needs to build core from source (-Z build-std).</a:t>
             </a:r>
             <a:endParaRPr lang="en-US" sz="1600" dirty="0"/>
           </a:p>
           <a:p>
-            <a:pPr algn="l" lvl="1" marL="203200" indent="-101600">
+            <a:pPr algn="l" marL="342900" indent="-342900">
               <a:lnSpc>
                 <a:spcPct val="115000"/>
               </a:lnSpc>
               <a:spcAft>
-                <a:spcPts val="400"/>
+                <a:spcPts val="200"/>
               </a:spcAft>
               <a:buSzPct val="100000"/>
-              <a:buChar char="◦"/>
+              <a:buChar char="●"/>
             </a:pPr>
             <a:r>
               <a:rPr lang="en-US" sz="1600" dirty="0">
@@ -5696,31 +5695,124 @@
                 <a:ea typeface="Red Hat Text" pitchFamily="34" charset="-122"/>
                 <a:cs typeface="Red Hat Text" pitchFamily="34" charset="-120"/>
               </a:rPr>
-              <a:t>A stable toolchain for the loader</a:t>
+              <a:t>bpf-linker</a:t>
             </a:r>
             <a:endParaRPr lang="en-US" sz="1600" dirty="0"/>
           </a:p>
           <a:p>
-            <a:pPr algn="l" lvl="1" marL="203200" indent="-101600">
+            <a:pPr algn="l" lvl="1" indent="0" marL="0">
               <a:lnSpc>
                 <a:spcPct val="115000"/>
               </a:lnSpc>
               <a:spcAft>
-                <a:spcPts val="400"/>
+                <a:spcPts val="600"/>
               </a:spcAft>
-              <a:buSzPct val="100000"/>
-              <a:buChar char="◦"/>
-            </a:pPr>
-            <a:r>
-              <a:rPr lang="en-US" sz="1600" dirty="0">
-                <a:solidFill>
-                  <a:srgbClr val="242424"/>
+              <a:buNone/>
+            </a:pPr>
+            <a:r>
+              <a:rPr lang="en-US" sz="1300" dirty="0">
+                <a:solidFill>
+                  <a:srgbClr val="5A5A5A"/>
                 </a:solidFill>
                 <a:latin typeface="Red Hat Text" pitchFamily="34" charset="0"/>
                 <a:ea typeface="Red Hat Text" pitchFamily="34" charset="-122"/>
                 <a:cs typeface="Red Hat Text" pitchFamily="34" charset="-120"/>
               </a:rPr>
+              <a:t>— cargo install bpf-linker; links your bytecode into a loadable object.</a:t>
+            </a:r>
+            <a:endParaRPr lang="en-US" sz="1600" dirty="0"/>
+          </a:p>
+          <a:p>
+            <a:pPr algn="l" marL="342900" indent="-342900">
+              <a:lnSpc>
+                <a:spcPct val="115000"/>
+              </a:lnSpc>
+              <a:spcAft>
+                <a:spcPts val="200"/>
+              </a:spcAft>
+              <a:buSzPct val="100000"/>
+              <a:buChar char="●"/>
+            </a:pPr>
+            <a:r>
+              <a:rPr lang="en-US" sz="1600" dirty="0">
+                <a:solidFill>
+                  <a:srgbClr val="242424"/>
+                </a:solidFill>
+                <a:latin typeface="Red Hat Text" pitchFamily="34" charset="0"/>
+                <a:ea typeface="Red Hat Text" pitchFamily="34" charset="-122"/>
+                <a:cs typeface="Red Hat Text" pitchFamily="34" charset="-120"/>
+              </a:rPr>
+              <a:t>A stable toolchain for the loader</a:t>
+            </a:r>
+            <a:endParaRPr lang="en-US" sz="1600" dirty="0"/>
+          </a:p>
+          <a:p>
+            <a:pPr algn="l" lvl="1" indent="0" marL="0">
+              <a:lnSpc>
+                <a:spcPct val="115000"/>
+              </a:lnSpc>
+              <a:spcAft>
+                <a:spcPts val="600"/>
+              </a:spcAft>
+              <a:buNone/>
+            </a:pPr>
+            <a:r>
+              <a:rPr lang="en-US" sz="1300" dirty="0">
+                <a:solidFill>
+                  <a:srgbClr val="5A5A5A"/>
+                </a:solidFill>
+                <a:latin typeface="Red Hat Text" pitchFamily="34" charset="0"/>
+                <a:ea typeface="Red Hat Text" pitchFamily="34" charset="-122"/>
+                <a:cs typeface="Red Hat Text" pitchFamily="34" charset="-120"/>
+              </a:rPr>
+              <a:t>— pinned per-crate via rust-toolchain.toml.</a:t>
+            </a:r>
+            <a:endParaRPr lang="en-US" sz="1600" dirty="0"/>
+          </a:p>
+          <a:p>
+            <a:pPr algn="l" marL="342900" indent="-342900">
+              <a:lnSpc>
+                <a:spcPct val="115000"/>
+              </a:lnSpc>
+              <a:spcAft>
+                <a:spcPts val="200"/>
+              </a:spcAft>
+              <a:buSzPct val="100000"/>
+              <a:buChar char="●"/>
+            </a:pPr>
+            <a:r>
+              <a:rPr lang="en-US" sz="1600" dirty="0">
+                <a:solidFill>
+                  <a:srgbClr val="242424"/>
+                </a:solidFill>
+                <a:latin typeface="Red Hat Text" pitchFamily="34" charset="0"/>
+                <a:ea typeface="Red Hat Text" pitchFamily="34" charset="-122"/>
+                <a:cs typeface="Red Hat Text" pitchFamily="34" charset="-120"/>
+              </a:rPr>
               <a:t>The lab: a Fedora VM with a recent kernel + BTF</a:t>
+            </a:r>
+            <a:endParaRPr lang="en-US" sz="1600" dirty="0"/>
+          </a:p>
+          <a:p>
+            <a:pPr algn="l" lvl="1" indent="0" marL="0">
+              <a:lnSpc>
+                <a:spcPct val="115000"/>
+              </a:lnSpc>
+              <a:spcAft>
+                <a:spcPts val="600"/>
+              </a:spcAft>
+              <a:buNone/>
+            </a:pPr>
+            <a:r>
+              <a:rPr lang="en-US" sz="1300" dirty="0">
+                <a:solidFill>
+                  <a:srgbClr val="5A5A5A"/>
+                </a:solidFill>
+                <a:latin typeface="Red Hat Text" pitchFamily="34" charset="0"/>
+                <a:ea typeface="Red Hat Text" pitchFamily="34" charset="-122"/>
+                <a:cs typeface="Red Hat Text" pitchFamily="34" charset="-120"/>
+              </a:rPr>
+              <a:t>— you build on the laptop, run on the VM.</a:t>
             </a:r>
             <a:endParaRPr lang="en-US" sz="1600" dirty="0"/>
           </a:p>
@@ -7032,15 +7124,15 @@
           <a:bodyPr wrap="square" rtlCol="0" anchor="t"/>
           <a:lstStyle/>
           <a:p>
-            <a:pPr algn="l" lvl="1" marL="203200" indent="-101600">
+            <a:pPr algn="l" marL="342900" indent="-342900">
               <a:lnSpc>
                 <a:spcPct val="115000"/>
               </a:lnSpc>
               <a:spcAft>
-                <a:spcPts val="400"/>
+                <a:spcPts val="200"/>
               </a:spcAft>
               <a:buSzPct val="100000"/>
-              <a:buChar char="◦"/>
+              <a:buChar char="●"/>
             </a:pPr>
             <a:r>
               <a:rPr lang="en-US" sz="1600" dirty="0">
@@ -7056,39 +7148,38 @@
             <a:endParaRPr lang="en-US" sz="1600" dirty="0"/>
           </a:p>
           <a:p>
-            <a:pPr algn="l" lvl="1" marL="203200" indent="-101600">
+            <a:pPr algn="l" lvl="1" indent="0" marL="0">
               <a:lnSpc>
                 <a:spcPct val="115000"/>
               </a:lnSpc>
               <a:spcAft>
-                <a:spcPts val="400"/>
+                <a:spcPts val="600"/>
               </a:spcAft>
-              <a:buSzPct val="100000"/>
-              <a:buChar char="◦"/>
-            </a:pPr>
-            <a:r>
-              <a:rPr lang="en-US" sz="1600" dirty="0">
-                <a:solidFill>
-                  <a:srgbClr val="242424"/>
+              <a:buNone/>
+            </a:pPr>
+            <a:r>
+              <a:rPr lang="en-US" sz="1300" dirty="0">
+                <a:solidFill>
+                  <a:srgbClr val="5A5A5A"/>
                 </a:solidFill>
                 <a:latin typeface="Red Hat Text" pitchFamily="34" charset="0"/>
                 <a:ea typeface="Red Hat Text" pitchFamily="34" charset="-122"/>
                 <a:cs typeface="Red Hat Text" pitchFamily="34" charset="-120"/>
               </a:rPr>
-              <a:t>deploy-to-target.sh ships it to the VM</a:t>
+              <a:t>— fast CPU, warm caches, your editor; produces the loader binary with embedded bytecode.</a:t>
             </a:r>
             <a:endParaRPr lang="en-US" sz="1600" dirty="0"/>
           </a:p>
           <a:p>
-            <a:pPr algn="l" lvl="1" marL="203200" indent="-101600">
+            <a:pPr algn="l" marL="342900" indent="-342900">
               <a:lnSpc>
                 <a:spcPct val="115000"/>
               </a:lnSpc>
               <a:spcAft>
-                <a:spcPts val="400"/>
+                <a:spcPts val="200"/>
               </a:spcAft>
               <a:buSzPct val="100000"/>
-              <a:buChar char="◦"/>
+              <a:buChar char="●"/>
             </a:pPr>
             <a:r>
               <a:rPr lang="en-US" sz="1600" dirty="0">
@@ -7099,31 +7190,124 @@
                 <a:ea typeface="Red Hat Text" pitchFamily="34" charset="-122"/>
                 <a:cs typeface="Red Hat Text" pitchFamily="34" charset="-120"/>
               </a:rPr>
-              <a:t>The VM exports OTLP back to the LGTM stack</a:t>
+              <a:t>deploy-to-target.sh ships it to the VM</a:t>
             </a:r>
             <a:endParaRPr lang="en-US" sz="1600" dirty="0"/>
           </a:p>
           <a:p>
-            <a:pPr algn="l" lvl="1" marL="203200" indent="-101600">
+            <a:pPr algn="l" lvl="1" indent="0" marL="0">
               <a:lnSpc>
                 <a:spcPct val="115000"/>
               </a:lnSpc>
               <a:spcAft>
-                <a:spcPts val="400"/>
+                <a:spcPts val="600"/>
               </a:spcAft>
-              <a:buSzPct val="100000"/>
-              <a:buChar char="◦"/>
-            </a:pPr>
-            <a:r>
-              <a:rPr lang="en-US" sz="1600" dirty="0">
-                <a:solidFill>
-                  <a:srgbClr val="242424"/>
+              <a:buNone/>
+            </a:pPr>
+            <a:r>
+              <a:rPr lang="en-US" sz="1300" dirty="0">
+                <a:solidFill>
+                  <a:srgbClr val="5A5A5A"/>
                 </a:solidFill>
                 <a:latin typeface="Red Hat Text" pitchFamily="34" charset="0"/>
                 <a:ea typeface="Red Hat Text" pitchFamily="34" charset="-122"/>
                 <a:cs typeface="Red Hat Text" pitchFamily="34" charset="-120"/>
               </a:rPr>
+              <a:t>and runs it under sudo (loading eBPF needs CAP_BPF).</a:t>
+            </a:r>
+            <a:endParaRPr lang="en-US" sz="1600" dirty="0"/>
+          </a:p>
+          <a:p>
+            <a:pPr algn="l" marL="342900" indent="-342900">
+              <a:lnSpc>
+                <a:spcPct val="115000"/>
+              </a:lnSpc>
+              <a:spcAft>
+                <a:spcPts val="200"/>
+              </a:spcAft>
+              <a:buSzPct val="100000"/>
+              <a:buChar char="●"/>
+            </a:pPr>
+            <a:r>
+              <a:rPr lang="en-US" sz="1600" dirty="0">
+                <a:solidFill>
+                  <a:srgbClr val="242424"/>
+                </a:solidFill>
+                <a:latin typeface="Red Hat Text" pitchFamily="34" charset="0"/>
+                <a:ea typeface="Red Hat Text" pitchFamily="34" charset="-122"/>
+                <a:cs typeface="Red Hat Text" pitchFamily="34" charset="-120"/>
+              </a:rPr>
+              <a:t>The VM exports OTLP back to the LGTM stack</a:t>
+            </a:r>
+            <a:endParaRPr lang="en-US" sz="1600" dirty="0"/>
+          </a:p>
+          <a:p>
+            <a:pPr algn="l" lvl="1" indent="0" marL="0">
+              <a:lnSpc>
+                <a:spcPct val="115000"/>
+              </a:lnSpc>
+              <a:spcAft>
+                <a:spcPts val="600"/>
+              </a:spcAft>
+              <a:buNone/>
+            </a:pPr>
+            <a:r>
+              <a:rPr lang="en-US" sz="1300" dirty="0">
+                <a:solidFill>
+                  <a:srgbClr val="5A5A5A"/>
+                </a:solidFill>
+                <a:latin typeface="Red Hat Text" pitchFamily="34" charset="0"/>
+                <a:ea typeface="Red Hat Text" pitchFamily="34" charset="-122"/>
+                <a:cs typeface="Red Hat Text" pitchFamily="34" charset="-120"/>
+              </a:rPr>
+              <a:t>running in a container on your laptop.</a:t>
+            </a:r>
+            <a:endParaRPr lang="en-US" sz="1600" dirty="0"/>
+          </a:p>
+          <a:p>
+            <a:pPr algn="l" marL="342900" indent="-342900">
+              <a:lnSpc>
+                <a:spcPct val="115000"/>
+              </a:lnSpc>
+              <a:spcAft>
+                <a:spcPts val="200"/>
+              </a:spcAft>
+              <a:buSzPct val="100000"/>
+              <a:buChar char="●"/>
+            </a:pPr>
+            <a:r>
+              <a:rPr lang="en-US" sz="1600" dirty="0">
+                <a:solidFill>
+                  <a:srgbClr val="242424"/>
+                </a:solidFill>
+                <a:latin typeface="Red Hat Text" pitchFamily="34" charset="0"/>
+                <a:ea typeface="Red Hat Text" pitchFamily="34" charset="-122"/>
+                <a:cs typeface="Red Hat Text" pitchFamily="34" charset="-120"/>
+              </a:rPr>
               <a:t>Each chapter is a demo.sh</a:t>
+            </a:r>
+            <a:endParaRPr lang="en-US" sz="1600" dirty="0"/>
+          </a:p>
+          <a:p>
+            <a:pPr algn="l" lvl="1" indent="0" marL="0">
+              <a:lnSpc>
+                <a:spcPct val="115000"/>
+              </a:lnSpc>
+              <a:spcAft>
+                <a:spcPts val="600"/>
+              </a:spcAft>
+              <a:buNone/>
+            </a:pPr>
+            <a:r>
+              <a:rPr lang="en-US" sz="1300" dirty="0">
+                <a:solidFill>
+                  <a:srgbClr val="5A5A5A"/>
+                </a:solidFill>
+                <a:latin typeface="Red Hat Text" pitchFamily="34" charset="0"/>
+                <a:ea typeface="Red Hat Text" pitchFamily="34" charset="-122"/>
+                <a:cs typeface="Red Hat Text" pitchFamily="34" charset="-120"/>
+              </a:rPr>
+              <a:t>— build, deploy, drive a workload, show the result in Grafana.</a:t>
             </a:r>
             <a:endParaRPr lang="en-US" sz="1600" dirty="0"/>
           </a:p>
@@ -7734,15 +7918,15 @@
           <a:bodyPr wrap="square" rtlCol="0" anchor="t"/>
           <a:lstStyle/>
           <a:p>
-            <a:pPr algn="l" lvl="1" marL="203200" indent="-101600">
+            <a:pPr algn="l" marL="342900" indent="-342900">
               <a:lnSpc>
                 <a:spcPct val="115000"/>
               </a:lnSpc>
               <a:spcAft>
-                <a:spcPts val="400"/>
+                <a:spcPts val="200"/>
               </a:spcAft>
               <a:buSzPct val="100000"/>
-              <a:buChar char="◦"/>
+              <a:buChar char="●"/>
             </a:pPr>
             <a:r>
               <a:rPr lang="en-US" sz="1600" dirty="0">
@@ -7758,39 +7942,38 @@
             <a:endParaRPr lang="en-US" sz="1600" dirty="0"/>
           </a:p>
           <a:p>
-            <a:pPr algn="l" lvl="1" marL="203200" indent="-101600">
+            <a:pPr algn="l" lvl="1" indent="0" marL="0">
               <a:lnSpc>
                 <a:spcPct val="115000"/>
               </a:lnSpc>
               <a:spcAft>
-                <a:spcPts val="400"/>
+                <a:spcPts val="600"/>
               </a:spcAft>
-              <a:buSzPct val="100000"/>
-              <a:buChar char="◦"/>
-            </a:pPr>
-            <a:r>
-              <a:rPr lang="en-US" sz="1600" dirty="0">
-                <a:solidFill>
-                  <a:srgbClr val="242424"/>
+              <a:buNone/>
+            </a:pPr>
+            <a:r>
+              <a:rPr lang="en-US" sz="1300" dirty="0">
+                <a:solidFill>
+                  <a:srgbClr val="5A5A5A"/>
                 </a:solidFill>
                 <a:latin typeface="Red Hat Text" pitchFamily="34" charset="0"/>
                 <a:ea typeface="Red Hat Text" pitchFamily="34" charset="-122"/>
                 <a:cs typeface="Red Hat Text" pitchFamily="34" charset="-120"/>
               </a:rPr>
-              <a:t>The safest tracing hook</a:t>
+              <a:t>— e.g. syscalls:sys_enter_execve, sched:sched_switch.</a:t>
             </a:r>
             <a:endParaRPr lang="en-US" sz="1600" dirty="0"/>
           </a:p>
           <a:p>
-            <a:pPr algn="l" lvl="1" marL="203200" indent="-101600">
+            <a:pPr algn="l" marL="342900" indent="-342900">
               <a:lnSpc>
                 <a:spcPct val="115000"/>
               </a:lnSpc>
               <a:spcAft>
-                <a:spcPts val="400"/>
+                <a:spcPts val="200"/>
               </a:spcAft>
               <a:buSzPct val="100000"/>
-              <a:buChar char="◦"/>
+              <a:buChar char="●"/>
             </a:pPr>
             <a:r>
               <a:rPr lang="en-US" sz="1600" dirty="0">
@@ -7801,31 +7984,124 @@
                 <a:ea typeface="Red Hat Text" pitchFamily="34" charset="-122"/>
                 <a:cs typeface="Red Hat Text" pitchFamily="34" charset="-120"/>
               </a:rPr>
-              <a:t>That's exactly what hello-world used</a:t>
+              <a:t>The safest tracing hook</a:t>
             </a:r>
             <a:endParaRPr lang="en-US" sz="1600" dirty="0"/>
           </a:p>
           <a:p>
-            <a:pPr algn="l" lvl="1" marL="203200" indent="-101600">
+            <a:pPr algn="l" lvl="1" indent="0" marL="0">
               <a:lnSpc>
                 <a:spcPct val="115000"/>
               </a:lnSpc>
               <a:spcAft>
-                <a:spcPts val="400"/>
+                <a:spcPts val="600"/>
               </a:spcAft>
-              <a:buSzPct val="100000"/>
-              <a:buChar char="◦"/>
-            </a:pPr>
-            <a:r>
-              <a:rPr lang="en-US" sz="1600" dirty="0">
-                <a:solidFill>
-                  <a:srgbClr val="242424"/>
+              <a:buNone/>
+            </a:pPr>
+            <a:r>
+              <a:rPr lang="en-US" sz="1300" dirty="0">
+                <a:solidFill>
+                  <a:srgbClr val="5A5A5A"/>
                 </a:solidFill>
                 <a:latin typeface="Red Hat Text" pitchFamily="34" charset="0"/>
                 <a:ea typeface="Red Hat Text" pitchFamily="34" charset="-122"/>
                 <a:cs typeface="Red Hat Text" pitchFamily="34" charset="-120"/>
               </a:rPr>
+              <a:t>— the kernel commits to keeping them, so your tool survives upgrades.</a:t>
+            </a:r>
+            <a:endParaRPr lang="en-US" sz="1600" dirty="0"/>
+          </a:p>
+          <a:p>
+            <a:pPr algn="l" marL="342900" indent="-342900">
+              <a:lnSpc>
+                <a:spcPct val="115000"/>
+              </a:lnSpc>
+              <a:spcAft>
+                <a:spcPts val="200"/>
+              </a:spcAft>
+              <a:buSzPct val="100000"/>
+              <a:buChar char="●"/>
+            </a:pPr>
+            <a:r>
+              <a:rPr lang="en-US" sz="1600" dirty="0">
+                <a:solidFill>
+                  <a:srgbClr val="242424"/>
+                </a:solidFill>
+                <a:latin typeface="Red Hat Text" pitchFamily="34" charset="0"/>
+                <a:ea typeface="Red Hat Text" pitchFamily="34" charset="-122"/>
+                <a:cs typeface="Red Hat Text" pitchFamily="34" charset="-120"/>
+              </a:rPr>
+              <a:t>That's exactly what hello-world used</a:t>
+            </a:r>
+            <a:endParaRPr lang="en-US" sz="1600" dirty="0"/>
+          </a:p>
+          <a:p>
+            <a:pPr algn="l" lvl="1" indent="0" marL="0">
+              <a:lnSpc>
+                <a:spcPct val="115000"/>
+              </a:lnSpc>
+              <a:spcAft>
+                <a:spcPts val="600"/>
+              </a:spcAft>
+              <a:buNone/>
+            </a:pPr>
+            <a:r>
+              <a:rPr lang="en-US" sz="1300" dirty="0">
+                <a:solidFill>
+                  <a:srgbClr val="5A5A5A"/>
+                </a:solidFill>
+                <a:latin typeface="Red Hat Text" pitchFamily="34" charset="0"/>
+                <a:ea typeface="Red Hat Text" pitchFamily="34" charset="-122"/>
+                <a:cs typeface="Red Hat Text" pitchFamily="34" charset="-120"/>
+              </a:rPr>
+              <a:t>— attach("syscalls", "sys_enter_execve") counts every process launch.</a:t>
+            </a:r>
+            <a:endParaRPr lang="en-US" sz="1600" dirty="0"/>
+          </a:p>
+          <a:p>
+            <a:pPr algn="l" marL="342900" indent="-342900">
+              <a:lnSpc>
+                <a:spcPct val="115000"/>
+              </a:lnSpc>
+              <a:spcAft>
+                <a:spcPts val="200"/>
+              </a:spcAft>
+              <a:buSzPct val="100000"/>
+              <a:buChar char="●"/>
+            </a:pPr>
+            <a:r>
+              <a:rPr lang="en-US" sz="1600" dirty="0">
+                <a:solidFill>
+                  <a:srgbClr val="242424"/>
+                </a:solidFill>
+                <a:latin typeface="Red Hat Text" pitchFamily="34" charset="0"/>
+                <a:ea typeface="Red Hat Text" pitchFamily="34" charset="-122"/>
+                <a:cs typeface="Red Hat Text" pitchFamily="34" charset="-120"/>
+              </a:rPr>
               <a:t>Great for syscall-level and scheduler-level observability</a:t>
+            </a:r>
+            <a:endParaRPr lang="en-US" sz="1600" dirty="0"/>
+          </a:p>
+          <a:p>
+            <a:pPr algn="l" lvl="1" indent="0" marL="0">
+              <a:lnSpc>
+                <a:spcPct val="115000"/>
+              </a:lnSpc>
+              <a:spcAft>
+                <a:spcPts val="600"/>
+              </a:spcAft>
+              <a:buNone/>
+            </a:pPr>
+            <a:r>
+              <a:rPr lang="en-US" sz="1300" dirty="0">
+                <a:solidFill>
+                  <a:srgbClr val="5A5A5A"/>
+                </a:solidFill>
+                <a:latin typeface="Red Hat Text" pitchFamily="34" charset="0"/>
+                <a:ea typeface="Red Hat Text" pitchFamily="34" charset="-122"/>
+                <a:cs typeface="Red Hat Text" pitchFamily="34" charset="-120"/>
+              </a:rPr>
+              <a:t>— execs, opens, signals, context switches.</a:t>
             </a:r>
             <a:endParaRPr lang="en-US" sz="1600" dirty="0"/>
           </a:p>
@@ -8042,15 +8318,15 @@
           <a:bodyPr wrap="square" rtlCol="0" anchor="t"/>
           <a:lstStyle/>
           <a:p>
-            <a:pPr algn="l" lvl="1" marL="203200" indent="-101600">
+            <a:pPr algn="l" marL="342900" indent="-342900">
               <a:lnSpc>
                 <a:spcPct val="115000"/>
               </a:lnSpc>
               <a:spcAft>
-                <a:spcPts val="400"/>
+                <a:spcPts val="200"/>
               </a:spcAft>
               <a:buSzPct val="100000"/>
-              <a:buChar char="◦"/>
+              <a:buChar char="●"/>
             </a:pPr>
             <a:r>
               <a:rPr lang="en-US" sz="1600" dirty="0">
@@ -8066,39 +8342,38 @@
             <a:endParaRPr lang="en-US" sz="1600" dirty="0"/>
           </a:p>
           <a:p>
-            <a:pPr algn="l" lvl="1" marL="203200" indent="-101600">
+            <a:pPr algn="l" lvl="1" indent="0" marL="0">
               <a:lnSpc>
                 <a:spcPct val="115000"/>
               </a:lnSpc>
               <a:spcAft>
-                <a:spcPts val="400"/>
+                <a:spcPts val="600"/>
               </a:spcAft>
-              <a:buSzPct val="100000"/>
-              <a:buChar char="◦"/>
-            </a:pPr>
-            <a:r>
-              <a:rPr lang="en-US" sz="1600" dirty="0">
-                <a:solidFill>
-                  <a:srgbClr val="242424"/>
+              <a:buNone/>
+            </a:pPr>
+            <a:r>
+              <a:rPr lang="en-US" sz="1300" dirty="0">
+                <a:solidFill>
+                  <a:srgbClr val="5A5A5A"/>
                 </a:solidFill>
                 <a:latin typeface="Red Hat Text" pitchFamily="34" charset="0"/>
                 <a:ea typeface="Red Hat Text" pitchFamily="34" charset="-122"/>
                 <a:cs typeface="Red Hat Text" pitchFamily="34" charset="-120"/>
               </a:rPr>
-              <a:t>Enormously powerful</a:t>
+              <a:t>— by name, at entry (kprobe) or return (kretprobe).</a:t>
             </a:r>
             <a:endParaRPr lang="en-US" sz="1600" dirty="0"/>
           </a:p>
           <a:p>
-            <a:pPr algn="l" lvl="1" marL="203200" indent="-101600">
+            <a:pPr algn="l" marL="342900" indent="-342900">
               <a:lnSpc>
                 <a:spcPct val="115000"/>
               </a:lnSpc>
               <a:spcAft>
-                <a:spcPts val="400"/>
+                <a:spcPts val="200"/>
               </a:spcAft>
               <a:buSzPct val="100000"/>
-              <a:buChar char="◦"/>
+              <a:buChar char="●"/>
             </a:pPr>
             <a:r>
               <a:rPr lang="en-US" sz="1600" dirty="0">
@@ -8109,31 +8384,124 @@
                 <a:ea typeface="Red Hat Text" pitchFamily="34" charset="-122"/>
                 <a:cs typeface="Red Hat Text" pitchFamily="34" charset="-120"/>
               </a:rPr>
-              <a:t>Less stable than tracepoints</a:t>
+              <a:t>Enormously powerful</a:t>
             </a:r>
             <a:endParaRPr lang="en-US" sz="1600" dirty="0"/>
           </a:p>
           <a:p>
-            <a:pPr algn="l" lvl="1" marL="203200" indent="-101600">
+            <a:pPr algn="l" lvl="1" indent="0" marL="0">
               <a:lnSpc>
                 <a:spcPct val="115000"/>
               </a:lnSpc>
               <a:spcAft>
-                <a:spcPts val="400"/>
+                <a:spcPts val="600"/>
               </a:spcAft>
-              <a:buSzPct val="100000"/>
-              <a:buChar char="◦"/>
-            </a:pPr>
-            <a:r>
-              <a:rPr lang="en-US" sz="1600" dirty="0">
-                <a:solidFill>
-                  <a:srgbClr val="242424"/>
+              <a:buNone/>
+            </a:pPr>
+            <a:r>
+              <a:rPr lang="en-US" sz="1300" dirty="0">
+                <a:solidFill>
+                  <a:srgbClr val="5A5A5A"/>
                 </a:solidFill>
                 <a:latin typeface="Red Hat Text" pitchFamily="34" charset="0"/>
                 <a:ea typeface="Red Hat Text" pitchFamily="34" charset="-122"/>
                 <a:cs typeface="Red Hat Text" pitchFamily="34" charset="-120"/>
               </a:rPr>
+              <a:t>— if the kernel calls a function, you can probably watch it.</a:t>
+            </a:r>
+            <a:endParaRPr lang="en-US" sz="1600" dirty="0"/>
+          </a:p>
+          <a:p>
+            <a:pPr algn="l" marL="342900" indent="-342900">
+              <a:lnSpc>
+                <a:spcPct val="115000"/>
+              </a:lnSpc>
+              <a:spcAft>
+                <a:spcPts val="200"/>
+              </a:spcAft>
+              <a:buSzPct val="100000"/>
+              <a:buChar char="●"/>
+            </a:pPr>
+            <a:r>
+              <a:rPr lang="en-US" sz="1600" dirty="0">
+                <a:solidFill>
+                  <a:srgbClr val="242424"/>
+                </a:solidFill>
+                <a:latin typeface="Red Hat Text" pitchFamily="34" charset="0"/>
+                <a:ea typeface="Red Hat Text" pitchFamily="34" charset="-122"/>
+                <a:cs typeface="Red Hat Text" pitchFamily="34" charset="-120"/>
+              </a:rPr>
+              <a:t>Less stable than tracepoints</a:t>
+            </a:r>
+            <a:endParaRPr lang="en-US" sz="1600" dirty="0"/>
+          </a:p>
+          <a:p>
+            <a:pPr algn="l" lvl="1" indent="0" marL="0">
+              <a:lnSpc>
+                <a:spcPct val="115000"/>
+              </a:lnSpc>
+              <a:spcAft>
+                <a:spcPts val="600"/>
+              </a:spcAft>
+              <a:buNone/>
+            </a:pPr>
+            <a:r>
+              <a:rPr lang="en-US" sz="1300" dirty="0">
+                <a:solidFill>
+                  <a:srgbClr val="5A5A5A"/>
+                </a:solidFill>
+                <a:latin typeface="Red Hat Text" pitchFamily="34" charset="0"/>
+                <a:ea typeface="Red Hat Text" pitchFamily="34" charset="-122"/>
+                <a:cs typeface="Red Hat Text" pitchFamily="34" charset="-120"/>
+              </a:rPr>
+              <a:t>— internal function names and signatures change between kernel versions.</a:t>
+            </a:r>
+            <a:endParaRPr lang="en-US" sz="1600" dirty="0"/>
+          </a:p>
+          <a:p>
+            <a:pPr algn="l" marL="342900" indent="-342900">
+              <a:lnSpc>
+                <a:spcPct val="115000"/>
+              </a:lnSpc>
+              <a:spcAft>
+                <a:spcPts val="200"/>
+              </a:spcAft>
+              <a:buSzPct val="100000"/>
+              <a:buChar char="●"/>
+            </a:pPr>
+            <a:r>
+              <a:rPr lang="en-US" sz="1600" dirty="0">
+                <a:solidFill>
+                  <a:srgbClr val="242424"/>
+                </a:solidFill>
+                <a:latin typeface="Red Hat Text" pitchFamily="34" charset="0"/>
+                <a:ea typeface="Red Hat Text" pitchFamily="34" charset="-122"/>
+                <a:cs typeface="Red Hat Text" pitchFamily="34" charset="-120"/>
+              </a:rPr>
               <a:t>A real gotcha we hit:</a:t>
+            </a:r>
+            <a:endParaRPr lang="en-US" sz="1600" dirty="0"/>
+          </a:p>
+          <a:p>
+            <a:pPr algn="l" lvl="1" indent="0" marL="0">
+              <a:lnSpc>
+                <a:spcPct val="115000"/>
+              </a:lnSpc>
+              <a:spcAft>
+                <a:spcPts val="600"/>
+              </a:spcAft>
+              <a:buNone/>
+            </a:pPr>
+            <a:r>
+              <a:rPr lang="en-US" sz="1300" dirty="0">
+                <a:solidFill>
+                  <a:srgbClr val="5A5A5A"/>
+                </a:solidFill>
+                <a:latin typeface="Red Hat Text" pitchFamily="34" charset="0"/>
+                <a:ea typeface="Red Hat Text" pitchFamily="34" charset="-122"/>
+                <a:cs typeface="Red Hat Text" pitchFamily="34" charset="-120"/>
+              </a:rPr>
+              <a:t>do_unlinkat was the classic file-deletion probe; on a newer kernel we retargeted to vfs_unlink.</a:t>
             </a:r>
             <a:endParaRPr lang="en-US" sz="1600" dirty="0"/>
           </a:p>
@@ -8389,15 +8757,15 @@
           <a:bodyPr wrap="square" rtlCol="0" anchor="t"/>
           <a:lstStyle/>
           <a:p>
-            <a:pPr algn="l" lvl="1" marL="203200" indent="-101600">
+            <a:pPr algn="l" marL="342900" indent="-342900">
               <a:lnSpc>
                 <a:spcPct val="115000"/>
               </a:lnSpc>
               <a:spcAft>
-                <a:spcPts val="400"/>
+                <a:spcPts val="200"/>
               </a:spcAft>
               <a:buSzPct val="100000"/>
-              <a:buChar char="◦"/>
+              <a:buChar char="●"/>
             </a:pPr>
             <a:r>
               <a:rPr lang="en-US" sz="1600" dirty="0">
@@ -8413,39 +8781,38 @@
             <a:endParaRPr lang="en-US" sz="1600" dirty="0"/>
           </a:p>
           <a:p>
-            <a:pPr algn="l" lvl="1" marL="203200" indent="-101600">
+            <a:pPr algn="l" lvl="1" indent="0" marL="0">
               <a:lnSpc>
                 <a:spcPct val="115000"/>
               </a:lnSpc>
               <a:spcAft>
-                <a:spcPts val="400"/>
+                <a:spcPts val="600"/>
               </a:spcAft>
-              <a:buSzPct val="100000"/>
-              <a:buChar char="◦"/>
-            </a:pPr>
-            <a:r>
-              <a:rPr lang="en-US" sz="1600" dirty="0">
-                <a:solidFill>
-                  <a:srgbClr val="242424"/>
+              <a:buNone/>
+            </a:pPr>
+            <a:r>
+              <a:rPr lang="en-US" sz="1300" dirty="0">
+                <a:solidFill>
+                  <a:srgbClr val="5A5A5A"/>
                 </a:solidFill>
                 <a:latin typeface="Red Hat Text" pitchFamily="34" charset="0"/>
                 <a:ea typeface="Red Hat Text" pitchFamily="34" charset="-122"/>
                 <a:cs typeface="Red Hat Text" pitchFamily="34" charset="-120"/>
               </a:rPr>
-              <a:t>BTF gives you typed arguments</a:t>
+              <a:t>— like kprobe/kretprobe, but lower overhead.</a:t>
             </a:r>
             <a:endParaRPr lang="en-US" sz="1600" dirty="0"/>
           </a:p>
           <a:p>
-            <a:pPr algn="l" lvl="1" marL="203200" indent="-101600">
+            <a:pPr algn="l" marL="342900" indent="-342900">
               <a:lnSpc>
                 <a:spcPct val="115000"/>
               </a:lnSpc>
               <a:spcAft>
-                <a:spcPts val="400"/>
+                <a:spcPts val="200"/>
               </a:spcAft>
               <a:buSzPct val="100000"/>
-              <a:buChar char="◦"/>
+              <a:buChar char="●"/>
             </a:pPr>
             <a:r>
               <a:rPr lang="en-US" sz="1600" dirty="0">
@@ -8456,31 +8823,124 @@
                 <a:ea typeface="Red Hat Text" pitchFamily="34" charset="-122"/>
                 <a:cs typeface="Red Hat Text" pitchFamily="34" charset="-120"/>
               </a:rPr>
-              <a:t>fexit sees both arguments and the return value</a:t>
+              <a:t>BTF gives you typed arguments</a:t>
             </a:r>
             <a:endParaRPr lang="en-US" sz="1600" dirty="0"/>
           </a:p>
           <a:p>
-            <a:pPr algn="l" lvl="1" marL="203200" indent="-101600">
+            <a:pPr algn="l" lvl="1" indent="0" marL="0">
               <a:lnSpc>
                 <a:spcPct val="115000"/>
               </a:lnSpc>
               <a:spcAft>
-                <a:spcPts val="400"/>
+                <a:spcPts val="600"/>
               </a:spcAft>
-              <a:buSzPct val="100000"/>
-              <a:buChar char="◦"/>
-            </a:pPr>
-            <a:r>
-              <a:rPr lang="en-US" sz="1600" dirty="0">
-                <a:solidFill>
-                  <a:srgbClr val="242424"/>
+              <a:buNone/>
+            </a:pPr>
+            <a:r>
+              <a:rPr lang="en-US" sz="1300" dirty="0">
+                <a:solidFill>
+                  <a:srgbClr val="5A5A5A"/>
                 </a:solidFill>
                 <a:latin typeface="Red Hat Text" pitchFamily="34" charset="0"/>
                 <a:ea typeface="Red Hat Text" pitchFamily="34" charset="-122"/>
                 <a:cs typeface="Red Hat Text" pitchFamily="34" charset="-120"/>
               </a:rPr>
+              <a:t>— the kernel's type info means you read args as real types, not raw offsets.</a:t>
+            </a:r>
+            <a:endParaRPr lang="en-US" sz="1600" dirty="0"/>
+          </a:p>
+          <a:p>
+            <a:pPr algn="l" marL="342900" indent="-342900">
+              <a:lnSpc>
+                <a:spcPct val="115000"/>
+              </a:lnSpc>
+              <a:spcAft>
+                <a:spcPts val="200"/>
+              </a:spcAft>
+              <a:buSzPct val="100000"/>
+              <a:buChar char="●"/>
+            </a:pPr>
+            <a:r>
+              <a:rPr lang="en-US" sz="1600" dirty="0">
+                <a:solidFill>
+                  <a:srgbClr val="242424"/>
+                </a:solidFill>
+                <a:latin typeface="Red Hat Text" pitchFamily="34" charset="0"/>
+                <a:ea typeface="Red Hat Text" pitchFamily="34" charset="-122"/>
+                <a:cs typeface="Red Hat Text" pitchFamily="34" charset="-120"/>
+              </a:rPr>
+              <a:t>fexit sees both arguments and the return value</a:t>
+            </a:r>
+            <a:endParaRPr lang="en-US" sz="1600" dirty="0"/>
+          </a:p>
+          <a:p>
+            <a:pPr algn="l" lvl="1" indent="0" marL="0">
+              <a:lnSpc>
+                <a:spcPct val="115000"/>
+              </a:lnSpc>
+              <a:spcAft>
+                <a:spcPts val="600"/>
+              </a:spcAft>
+              <a:buNone/>
+            </a:pPr>
+            <a:r>
+              <a:rPr lang="en-US" sz="1300" dirty="0">
+                <a:solidFill>
+                  <a:srgbClr val="5A5A5A"/>
+                </a:solidFill>
+                <a:latin typeface="Red Hat Text" pitchFamily="34" charset="0"/>
+                <a:ea typeface="Red Hat Text" pitchFamily="34" charset="-122"/>
+                <a:cs typeface="Red Hat Text" pitchFamily="34" charset="-120"/>
+              </a:rPr>
+              <a:t>— perfect for 'did this succeed, and how long did it take?'</a:t>
+            </a:r>
+            <a:endParaRPr lang="en-US" sz="1600" dirty="0"/>
+          </a:p>
+          <a:p>
+            <a:pPr algn="l" marL="342900" indent="-342900">
+              <a:lnSpc>
+                <a:spcPct val="115000"/>
+              </a:lnSpc>
+              <a:spcAft>
+                <a:spcPts val="200"/>
+              </a:spcAft>
+              <a:buSzPct val="100000"/>
+              <a:buChar char="●"/>
+            </a:pPr>
+            <a:r>
+              <a:rPr lang="en-US" sz="1600" dirty="0">
+                <a:solidFill>
+                  <a:srgbClr val="242424"/>
+                </a:solidFill>
+                <a:latin typeface="Red Hat Text" pitchFamily="34" charset="0"/>
+                <a:ea typeface="Red Hat Text" pitchFamily="34" charset="-122"/>
+                <a:cs typeface="Red Hat Text" pitchFamily="34" charset="-120"/>
+              </a:rPr>
               <a:t>Our vfs_unlink example uses fentry + fexit</a:t>
+            </a:r>
+            <a:endParaRPr lang="en-US" sz="1600" dirty="0"/>
+          </a:p>
+          <a:p>
+            <a:pPr algn="l" lvl="1" indent="0" marL="0">
+              <a:lnSpc>
+                <a:spcPct val="115000"/>
+              </a:lnSpc>
+              <a:spcAft>
+                <a:spcPts val="600"/>
+              </a:spcAft>
+              <a:buNone/>
+            </a:pPr>
+            <a:r>
+              <a:rPr lang="en-US" sz="1300" dirty="0">
+                <a:solidFill>
+                  <a:srgbClr val="5A5A5A"/>
+                </a:solidFill>
+                <a:latin typeface="Red Hat Text" pitchFamily="34" charset="0"/>
+                <a:ea typeface="Red Hat Text" pitchFamily="34" charset="-122"/>
+                <a:cs typeface="Red Hat Text" pitchFamily="34" charset="-120"/>
+              </a:rPr>
+              <a:t>— entry captures who/what; exit captures the result.</a:t>
             </a:r>
             <a:endParaRPr lang="en-US" sz="1600" dirty="0"/>
           </a:p>
@@ -9189,15 +9649,15 @@
           <a:bodyPr wrap="square" rtlCol="0" anchor="t"/>
           <a:lstStyle/>
           <a:p>
-            <a:pPr algn="l" lvl="1" marL="203200" indent="-101600">
+            <a:pPr algn="l" marL="342900" indent="-342900">
               <a:lnSpc>
                 <a:spcPct val="115000"/>
               </a:lnSpc>
               <a:spcAft>
-                <a:spcPts val="400"/>
+                <a:spcPts val="200"/>
               </a:spcAft>
               <a:buSzPct val="100000"/>
-              <a:buChar char="◦"/>
+              <a:buChar char="●"/>
             </a:pPr>
             <a:r>
               <a:rPr lang="en-US" sz="1600" dirty="0">
@@ -9213,39 +9673,38 @@
             <a:endParaRPr lang="en-US" sz="1600" dirty="0"/>
           </a:p>
           <a:p>
-            <a:pPr algn="l" lvl="1" marL="203200" indent="-101600">
+            <a:pPr algn="l" lvl="1" indent="0" marL="0">
               <a:lnSpc>
                 <a:spcPct val="115000"/>
               </a:lnSpc>
               <a:spcAft>
-                <a:spcPts val="400"/>
+                <a:spcPts val="600"/>
               </a:spcAft>
-              <a:buSzPct val="100000"/>
-              <a:buChar char="◦"/>
-            </a:pPr>
-            <a:r>
-              <a:rPr lang="en-US" sz="1600" dirty="0">
-                <a:solidFill>
-                  <a:srgbClr val="242424"/>
+              <a:buNone/>
+            </a:pPr>
+            <a:r>
+              <a:rPr lang="en-US" sz="1300" dirty="0">
+                <a:solidFill>
+                  <a:srgbClr val="5A5A5A"/>
                 </a:solidFill>
                 <a:latin typeface="Red Hat Text" pitchFamily="34" charset="0"/>
                 <a:ea typeface="Red Hat Text" pitchFamily="34" charset="-122"/>
                 <a:cs typeface="Red Hat Text" pitchFamily="34" charset="-120"/>
               </a:rPr>
-              <a:t>See plaintext before encryption, queries before they hit the wire, GC pauses inside the JVM.</a:t>
+              <a:t>— not the kernel: libssl, libjvm, libpq, your own app.</a:t>
             </a:r>
             <a:endParaRPr lang="en-US" sz="1600" dirty="0"/>
           </a:p>
           <a:p>
-            <a:pPr algn="l" lvl="1" marL="203200" indent="-101600">
+            <a:pPr algn="l" marL="342900" indent="-342900">
               <a:lnSpc>
                 <a:spcPct val="115000"/>
               </a:lnSpc>
               <a:spcAft>
-                <a:spcPts val="400"/>
+                <a:spcPts val="200"/>
               </a:spcAft>
               <a:buSzPct val="100000"/>
-              <a:buChar char="◦"/>
+              <a:buChar char="●"/>
             </a:pPr>
             <a:r>
               <a:rPr lang="en-US" sz="1600" dirty="0">
@@ -9256,31 +9715,124 @@
                 <a:ea typeface="Red Hat Text" pitchFamily="34" charset="-122"/>
                 <a:cs typeface="Red Hat Text" pitchFamily="34" charset="-120"/>
               </a:rPr>
-              <a:t>Resolve the symbol, attach a uprobe at its offset</a:t>
+              <a:t>See plaintext before encryption, queries before they hit the wire, GC pauses inside the JVM.</a:t>
             </a:r>
             <a:endParaRPr lang="en-US" sz="1600" dirty="0"/>
           </a:p>
           <a:p>
-            <a:pPr algn="l" lvl="1" marL="203200" indent="-101600">
+            <a:pPr algn="l" lvl="1" indent="0" marL="0">
               <a:lnSpc>
                 <a:spcPct val="115000"/>
               </a:lnSpc>
               <a:spcAft>
-                <a:spcPts val="400"/>
+                <a:spcPts val="600"/>
               </a:spcAft>
-              <a:buSzPct val="100000"/>
-              <a:buChar char="◦"/>
-            </a:pPr>
-            <a:r>
-              <a:rPr lang="en-US" sz="1600" dirty="0">
-                <a:solidFill>
-                  <a:srgbClr val="242424"/>
+              <a:buNone/>
+            </a:pPr>
+            <a:r>
+              <a:rPr lang="en-US" sz="1300" dirty="0">
+                <a:solidFill>
+                  <a:srgbClr val="5A5A5A"/>
                 </a:solidFill>
                 <a:latin typeface="Red Hat Text" pitchFamily="34" charset="0"/>
                 <a:ea typeface="Red Hat Text" pitchFamily="34" charset="-122"/>
                 <a:cs typeface="Red Hat Text" pitchFamily="34" charset="-120"/>
               </a:rPr>
+              <a:t>— because you're inside the process's own functions.</a:t>
+            </a:r>
+            <a:endParaRPr lang="en-US" sz="1600" dirty="0"/>
+          </a:p>
+          <a:p>
+            <a:pPr algn="l" marL="342900" indent="-342900">
+              <a:lnSpc>
+                <a:spcPct val="115000"/>
+              </a:lnSpc>
+              <a:spcAft>
+                <a:spcPts val="200"/>
+              </a:spcAft>
+              <a:buSzPct val="100000"/>
+              <a:buChar char="●"/>
+            </a:pPr>
+            <a:r>
+              <a:rPr lang="en-US" sz="1600" dirty="0">
+                <a:solidFill>
+                  <a:srgbClr val="242424"/>
+                </a:solidFill>
+                <a:latin typeface="Red Hat Text" pitchFamily="34" charset="0"/>
+                <a:ea typeface="Red Hat Text" pitchFamily="34" charset="-122"/>
+                <a:cs typeface="Red Hat Text" pitchFamily="34" charset="-120"/>
+              </a:rPr>
+              <a:t>Resolve the symbol, attach a uprobe at its offset</a:t>
+            </a:r>
+            <a:endParaRPr lang="en-US" sz="1600" dirty="0"/>
+          </a:p>
+          <a:p>
+            <a:pPr algn="l" lvl="1" indent="0" marL="0">
+              <a:lnSpc>
+                <a:spcPct val="115000"/>
+              </a:lnSpc>
+              <a:spcAft>
+                <a:spcPts val="600"/>
+              </a:spcAft>
+              <a:buNone/>
+            </a:pPr>
+            <a:r>
+              <a:rPr lang="en-US" sz="1300" dirty="0">
+                <a:solidFill>
+                  <a:srgbClr val="5A5A5A"/>
+                </a:solidFill>
+                <a:latin typeface="Red Hat Text" pitchFamily="34" charset="0"/>
+                <a:ea typeface="Red Hat Text" pitchFamily="34" charset="-122"/>
+                <a:cs typeface="Red Hat Text" pitchFamily="34" charset="-120"/>
+              </a:rPr>
+              <a:t>— Aya reads the binary's symbol table for you.</a:t>
+            </a:r>
+            <a:endParaRPr lang="en-US" sz="1600" dirty="0"/>
+          </a:p>
+          <a:p>
+            <a:pPr algn="l" marL="342900" indent="-342900">
+              <a:lnSpc>
+                <a:spcPct val="115000"/>
+              </a:lnSpc>
+              <a:spcAft>
+                <a:spcPts val="200"/>
+              </a:spcAft>
+              <a:buSzPct val="100000"/>
+              <a:buChar char="●"/>
+            </a:pPr>
+            <a:r>
+              <a:rPr lang="en-US" sz="1600" dirty="0">
+                <a:solidFill>
+                  <a:srgbClr val="242424"/>
+                </a:solidFill>
+                <a:latin typeface="Red Hat Text" pitchFamily="34" charset="0"/>
+                <a:ea typeface="Red Hat Text" pitchFamily="34" charset="-122"/>
+                <a:cs typeface="Red Hat Text" pitchFamily="34" charset="-120"/>
+              </a:rPr>
               <a:t>Examples: sslsniff (OpenSSL), the Postgres query probe, JVM GC timing.</a:t>
+            </a:r>
+            <a:endParaRPr lang="en-US" sz="1600" dirty="0"/>
+          </a:p>
+          <a:p>
+            <a:pPr algn="l" lvl="1" indent="0" marL="0">
+              <a:lnSpc>
+                <a:spcPct val="115000"/>
+              </a:lnSpc>
+              <a:spcAft>
+                <a:spcPts val="600"/>
+              </a:spcAft>
+              <a:buNone/>
+            </a:pPr>
+            <a:r>
+              <a:rPr lang="en-US" sz="1300" dirty="0">
+                <a:solidFill>
+                  <a:srgbClr val="5A5A5A"/>
+                </a:solidFill>
+                <a:latin typeface="Red Hat Text" pitchFamily="34" charset="0"/>
+                <a:ea typeface="Red Hat Text" pitchFamily="34" charset="-122"/>
+                <a:cs typeface="Red Hat Text" pitchFamily="34" charset="-120"/>
+              </a:rPr>
+              <a:t>— all uprobes into a library or binary.</a:t>
             </a:r>
             <a:endParaRPr lang="en-US" sz="1600" dirty="0"/>
           </a:p>
@@ -10624,15 +11176,15 @@
           <a:bodyPr wrap="square" rtlCol="0" anchor="t"/>
           <a:lstStyle/>
           <a:p>
-            <a:pPr algn="l" lvl="1" marL="203200" indent="-101600">
+            <a:pPr algn="l" marL="342900" indent="-342900">
               <a:lnSpc>
                 <a:spcPct val="115000"/>
               </a:lnSpc>
               <a:spcAft>
-                <a:spcPts val="400"/>
+                <a:spcPts val="200"/>
               </a:spcAft>
               <a:buSzPct val="100000"/>
-              <a:buChar char="◦"/>
+              <a:buChar char="●"/>
             </a:pPr>
             <a:r>
               <a:rPr lang="en-US" sz="1600" dirty="0">
@@ -10648,39 +11200,38 @@
             <a:endParaRPr lang="en-US" sz="1600" dirty="0"/>
           </a:p>
           <a:p>
-            <a:pPr algn="l" lvl="1" marL="203200" indent="-101600">
+            <a:pPr algn="l" lvl="1" indent="0" marL="0">
               <a:lnSpc>
                 <a:spcPct val="115000"/>
               </a:lnSpc>
               <a:spcAft>
-                <a:spcPts val="400"/>
+                <a:spcPts val="600"/>
               </a:spcAft>
-              <a:buSzPct val="100000"/>
-              <a:buChar char="◦"/>
-            </a:pPr>
-            <a:r>
-              <a:rPr lang="en-US" sz="1600" dirty="0">
-                <a:solidFill>
-                  <a:srgbClr val="242424"/>
+              <a:buNone/>
+            </a:pPr>
+            <a:r>
+              <a:rPr lang="en-US" sz="1300" dirty="0">
+                <a:solidFill>
+                  <a:srgbClr val="5A5A5A"/>
                 </a:solidFill>
                 <a:latin typeface="Red Hat Text" pitchFamily="34" charset="0"/>
                 <a:ea typeface="Red Hat Text" pitchFamily="34" charset="-122"/>
                 <a:cs typeface="Red Hat Text" pitchFamily="34" charset="-120"/>
               </a:rPr>
-              <a:t>tcx is the modern, cleaner attach point</a:t>
+              <a:t>— by then the kernel's packet structure exists, so you have more context.</a:t>
             </a:r>
             <a:endParaRPr lang="en-US" sz="1600" dirty="0"/>
           </a:p>
           <a:p>
-            <a:pPr algn="l" lvl="1" marL="203200" indent="-101600">
+            <a:pPr algn="l" marL="342900" indent="-342900">
               <a:lnSpc>
                 <a:spcPct val="115000"/>
               </a:lnSpc>
               <a:spcAft>
-                <a:spcPts val="400"/>
+                <a:spcPts val="200"/>
               </a:spcAft>
               <a:buSzPct val="100000"/>
-              <a:buChar char="◦"/>
+              <a:buChar char="●"/>
             </a:pPr>
             <a:r>
               <a:rPr lang="en-US" sz="1600" dirty="0">
@@ -10691,7 +11242,77 @@
                 <a:ea typeface="Red Hat Text" pitchFamily="34" charset="-122"/>
                 <a:cs typeface="Red Hat Text" pitchFamily="34" charset="-120"/>
               </a:rPr>
+              <a:t>tcx is the modern, cleaner attach point</a:t>
+            </a:r>
+            <a:endParaRPr lang="en-US" sz="1600" dirty="0"/>
+          </a:p>
+          <a:p>
+            <a:pPr algn="l" lvl="1" indent="0" marL="0">
+              <a:lnSpc>
+                <a:spcPct val="115000"/>
+              </a:lnSpc>
+              <a:spcAft>
+                <a:spcPts val="600"/>
+              </a:spcAft>
+              <a:buNone/>
+            </a:pPr>
+            <a:r>
+              <a:rPr lang="en-US" sz="1300" dirty="0">
+                <a:solidFill>
+                  <a:srgbClr val="5A5A5A"/>
+                </a:solidFill>
+                <a:latin typeface="Red Hat Text" pitchFamily="34" charset="0"/>
+                <a:ea typeface="Red Hat Text" pitchFamily="34" charset="-122"/>
+                <a:cs typeface="Red Hat Text" pitchFamily="34" charset="-120"/>
+              </a:rPr>
+              <a:t>— composable, with a well-defined ordering of programs.</a:t>
+            </a:r>
+            <a:endParaRPr lang="en-US" sz="1600" dirty="0"/>
+          </a:p>
+          <a:p>
+            <a:pPr algn="l" marL="342900" indent="-342900">
+              <a:lnSpc>
+                <a:spcPct val="115000"/>
+              </a:lnSpc>
+              <a:spcAft>
+                <a:spcPts val="200"/>
+              </a:spcAft>
+              <a:buSzPct val="100000"/>
+              <a:buChar char="●"/>
+            </a:pPr>
+            <a:r>
+              <a:rPr lang="en-US" sz="1600" dirty="0">
+                <a:solidFill>
+                  <a:srgbClr val="242424"/>
+                </a:solidFill>
+                <a:latin typeface="Red Hat Text" pitchFamily="34" charset="0"/>
+                <a:ea typeface="Red Hat Text" pitchFamily="34" charset="-122"/>
+                <a:cs typeface="Red Hat Text" pitchFamily="34" charset="-120"/>
+              </a:rPr>
               <a:t>Use it to classify, shape, count, or redirect</a:t>
+            </a:r>
+            <a:endParaRPr lang="en-US" sz="1600" dirty="0"/>
+          </a:p>
+          <a:p>
+            <a:pPr algn="l" lvl="1" indent="0" marL="0">
+              <a:lnSpc>
+                <a:spcPct val="115000"/>
+              </a:lnSpc>
+              <a:spcAft>
+                <a:spcPts val="600"/>
+              </a:spcAft>
+              <a:buNone/>
+            </a:pPr>
+            <a:r>
+              <a:rPr lang="en-US" sz="1300" dirty="0">
+                <a:solidFill>
+                  <a:srgbClr val="5A5A5A"/>
+                </a:solidFill>
+                <a:latin typeface="Red Hat Text" pitchFamily="34" charset="0"/>
+                <a:ea typeface="Red Hat Text" pitchFamily="34" charset="-122"/>
+                <a:cs typeface="Red Hat Text" pitchFamily="34" charset="-120"/>
+              </a:rPr>
+              <a:t>— per-connection and per-cgroup policy lives here.</a:t>
             </a:r>
             <a:endParaRPr lang="en-US" sz="1600" dirty="0"/>
           </a:p>
@@ -10956,15 +11577,15 @@
             <a:endParaRPr lang="en-US" sz="1700" dirty="0"/>
           </a:p>
           <a:p>
-            <a:pPr algn="l" lvl="1" marL="203200" indent="-101600">
+            <a:pPr algn="l" marL="342900" indent="-342900">
               <a:lnSpc>
                 <a:spcPct val="115000"/>
               </a:lnSpc>
               <a:spcAft>
-                <a:spcPts val="400"/>
+                <a:spcPts val="200"/>
               </a:spcAft>
               <a:buSzPct val="100000"/>
-              <a:buChar char="◦"/>
+              <a:buChar char="●"/>
             </a:pPr>
             <a:r>
               <a:rPr lang="en-US" sz="1700" dirty="0">
@@ -10980,26 +11601,72 @@
             <a:endParaRPr lang="en-US" sz="1700" dirty="0"/>
           </a:p>
           <a:p>
-            <a:pPr algn="l" lvl="1" marL="203200" indent="-101600">
+            <a:pPr algn="l" lvl="1" indent="0" marL="0">
               <a:lnSpc>
                 <a:spcPct val="115000"/>
               </a:lnSpc>
               <a:spcAft>
-                <a:spcPts val="400"/>
+                <a:spcPts val="600"/>
               </a:spcAft>
-              <a:buSzPct val="100000"/>
-              <a:buChar char="◦"/>
-            </a:pPr>
-            <a:r>
-              <a:rPr lang="en-US" sz="1700" dirty="0">
-                <a:solidFill>
-                  <a:srgbClr val="242424"/>
+              <a:buNone/>
+            </a:pPr>
+            <a:r>
+              <a:rPr lang="en-US" sz="1400" dirty="0">
+                <a:solidFill>
+                  <a:srgbClr val="5A5A5A"/>
                 </a:solidFill>
                 <a:latin typeface="Red Hat Text" pitchFamily="34" charset="0"/>
                 <a:ea typeface="Red Hat Text" pitchFamily="34" charset="-122"/>
                 <a:cs typeface="Red Hat Text" pitchFamily="34" charset="-120"/>
               </a:rPr>
+              <a:t>a verifier proves your program can't crash or hang the kernel before it ever runs.</a:t>
+            </a:r>
+            <a:endParaRPr lang="en-US" sz="1700" dirty="0"/>
+          </a:p>
+          <a:p>
+            <a:pPr algn="l" marL="342900" indent="-342900">
+              <a:lnSpc>
+                <a:spcPct val="115000"/>
+              </a:lnSpc>
+              <a:spcAft>
+                <a:spcPts val="200"/>
+              </a:spcAft>
+              <a:buSzPct val="100000"/>
+              <a:buChar char="●"/>
+            </a:pPr>
+            <a:r>
+              <a:rPr lang="en-US" sz="1700" dirty="0">
+                <a:solidFill>
+                  <a:srgbClr val="242424"/>
+                </a:solidFill>
+                <a:latin typeface="Red Hat Text" pitchFamily="34" charset="0"/>
+                <a:ea typeface="Red Hat Text" pitchFamily="34" charset="-122"/>
+                <a:cs typeface="Red Hat Text" pitchFamily="34" charset="-120"/>
+              </a:rPr>
               <a:t>Fast:</a:t>
+            </a:r>
+            <a:endParaRPr lang="en-US" sz="1700" dirty="0"/>
+          </a:p>
+          <a:p>
+            <a:pPr algn="l" lvl="1" indent="0" marL="0">
+              <a:lnSpc>
+                <a:spcPct val="115000"/>
+              </a:lnSpc>
+              <a:spcAft>
+                <a:spcPts val="600"/>
+              </a:spcAft>
+              <a:buNone/>
+            </a:pPr>
+            <a:r>
+              <a:rPr lang="en-US" sz="1400" dirty="0">
+                <a:solidFill>
+                  <a:srgbClr val="5A5A5A"/>
+                </a:solidFill>
+                <a:latin typeface="Red Hat Text" pitchFamily="34" charset="0"/>
+                <a:ea typeface="Red Hat Text" pitchFamily="34" charset="-122"/>
+                <a:cs typeface="Red Hat Text" pitchFamily="34" charset="-120"/>
+              </a:rPr>
+              <a:t>the bytecode is JIT-compiled to native instructions — kernel speed, not interpreter speed.</a:t>
             </a:r>
             <a:endParaRPr lang="en-US" sz="1700" dirty="0"/>
           </a:p>
@@ -12893,15 +13560,15 @@
           <a:bodyPr wrap="square" rtlCol="0" anchor="t"/>
           <a:lstStyle/>
           <a:p>
-            <a:pPr algn="l" lvl="1" marL="203200" indent="-101600">
+            <a:pPr algn="l" marL="342900" indent="-342900">
               <a:lnSpc>
                 <a:spcPct val="115000"/>
               </a:lnSpc>
               <a:spcAft>
-                <a:spcPts val="400"/>
+                <a:spcPts val="200"/>
               </a:spcAft>
               <a:buSzPct val="100000"/>
-              <a:buChar char="◦"/>
+              <a:buChar char="●"/>
             </a:pPr>
             <a:r>
               <a:rPr lang="en-US" sz="1600" dirty="0">
@@ -12917,39 +13584,38 @@
             <a:endParaRPr lang="en-US" sz="1600" dirty="0"/>
           </a:p>
           <a:p>
-            <a:pPr algn="l" lvl="1" marL="203200" indent="-101600">
+            <a:pPr algn="l" lvl="1" indent="0" marL="0">
               <a:lnSpc>
                 <a:spcPct val="115000"/>
               </a:lnSpc>
               <a:spcAft>
-                <a:spcPts val="400"/>
+                <a:spcPts val="600"/>
               </a:spcAft>
-              <a:buSzPct val="100000"/>
-              <a:buChar char="◦"/>
-            </a:pPr>
-            <a:r>
-              <a:rPr lang="en-US" sz="1600" dirty="0">
-                <a:solidFill>
-                  <a:srgbClr val="242424"/>
+              <a:buNone/>
+            </a:pPr>
+            <a:r>
+              <a:rPr lang="en-US" sz="1300" dirty="0">
+                <a:solidFill>
+                  <a:srgbClr val="5A5A5A"/>
                 </a:solidFill>
                 <a:latin typeface="Red Hat Text" pitchFamily="34" charset="0"/>
                 <a:ea typeface="Red Hat Text" pitchFamily="34" charset="-122"/>
                 <a:cs typeface="Red Hat Text" pitchFamily="34" charset="-120"/>
               </a:rPr>
-              <a:t>Latency histograms</a:t>
+              <a:t>— e.g. sum(rate(ebpf_events_total[1m])) — execs per second, straight from the tracepoint.</a:t>
             </a:r>
             <a:endParaRPr lang="en-US" sz="1600" dirty="0"/>
           </a:p>
           <a:p>
-            <a:pPr algn="l" lvl="1" marL="203200" indent="-101600">
+            <a:pPr algn="l" marL="342900" indent="-342900">
               <a:lnSpc>
                 <a:spcPct val="115000"/>
               </a:lnSpc>
               <a:spcAft>
-                <a:spcPts val="400"/>
+                <a:spcPts val="200"/>
               </a:spcAft>
               <a:buSzPct val="100000"/>
-              <a:buChar char="◦"/>
+              <a:buChar char="●"/>
             </a:pPr>
             <a:r>
               <a:rPr lang="en-US" sz="1600" dirty="0">
@@ -12960,31 +13626,124 @@
                 <a:ea typeface="Red Hat Text" pitchFamily="34" charset="-122"/>
                 <a:cs typeface="Red Hat Text" pitchFamily="34" charset="-120"/>
               </a:rPr>
-              <a:t>Per-target labels</a:t>
+              <a:t>Latency histograms</a:t>
             </a:r>
             <a:endParaRPr lang="en-US" sz="1600" dirty="0"/>
           </a:p>
           <a:p>
-            <a:pPr algn="l" lvl="1" marL="203200" indent="-101600">
+            <a:pPr algn="l" lvl="1" indent="0" marL="0">
               <a:lnSpc>
                 <a:spcPct val="115000"/>
               </a:lnSpc>
               <a:spcAft>
-                <a:spcPts val="400"/>
+                <a:spcPts val="600"/>
               </a:spcAft>
-              <a:buSzPct val="100000"/>
-              <a:buChar char="◦"/>
-            </a:pPr>
-            <a:r>
-              <a:rPr lang="en-US" sz="1600" dirty="0">
-                <a:solidFill>
-                  <a:srgbClr val="242424"/>
+              <a:buNone/>
+            </a:pPr>
+            <a:r>
+              <a:rPr lang="en-US" sz="1300" dirty="0">
+                <a:solidFill>
+                  <a:srgbClr val="5A5A5A"/>
                 </a:solidFill>
                 <a:latin typeface="Red Hat Text" pitchFamily="34" charset="0"/>
                 <a:ea typeface="Red Hat Text" pitchFamily="34" charset="-122"/>
                 <a:cs typeface="Red Hat Text" pitchFamily="34" charset="-120"/>
               </a:rPr>
+              <a:t>— function or request latency as a heatmap and p99 line, from ring-buffer events.</a:t>
+            </a:r>
+            <a:endParaRPr lang="en-US" sz="1600" dirty="0"/>
+          </a:p>
+          <a:p>
+            <a:pPr algn="l" marL="342900" indent="-342900">
+              <a:lnSpc>
+                <a:spcPct val="115000"/>
+              </a:lnSpc>
+              <a:spcAft>
+                <a:spcPts val="200"/>
+              </a:spcAft>
+              <a:buSzPct val="100000"/>
+              <a:buChar char="●"/>
+            </a:pPr>
+            <a:r>
+              <a:rPr lang="en-US" sz="1600" dirty="0">
+                <a:solidFill>
+                  <a:srgbClr val="242424"/>
+                </a:solidFill>
+                <a:latin typeface="Red Hat Text" pitchFamily="34" charset="0"/>
+                <a:ea typeface="Red Hat Text" pitchFamily="34" charset="-122"/>
+                <a:cs typeface="Red Hat Text" pitchFamily="34" charset="-120"/>
+              </a:rPr>
+              <a:t>Per-target labels</a:t>
+            </a:r>
+            <a:endParaRPr lang="en-US" sz="1600" dirty="0"/>
+          </a:p>
+          <a:p>
+            <a:pPr algn="l" lvl="1" indent="0" marL="0">
+              <a:lnSpc>
+                <a:spcPct val="115000"/>
+              </a:lnSpc>
+              <a:spcAft>
+                <a:spcPts val="600"/>
+              </a:spcAft>
+              <a:buNone/>
+            </a:pPr>
+            <a:r>
+              <a:rPr lang="en-US" sz="1300" dirty="0">
+                <a:solidFill>
+                  <a:srgbClr val="5A5A5A"/>
+                </a:solidFill>
+                <a:latin typeface="Red Hat Text" pitchFamily="34" charset="0"/>
+                <a:ea typeface="Red Hat Text" pitchFamily="34" charset="-122"/>
+                <a:cs typeface="Red Hat Text" pitchFamily="34" charset="-120"/>
+              </a:rPr>
+              <a:t>— break down by program, by container, by result — the kernel event, sliced.</a:t>
+            </a:r>
+            <a:endParaRPr lang="en-US" sz="1600" dirty="0"/>
+          </a:p>
+          <a:p>
+            <a:pPr algn="l" marL="342900" indent="-342900">
+              <a:lnSpc>
+                <a:spcPct val="115000"/>
+              </a:lnSpc>
+              <a:spcAft>
+                <a:spcPts val="200"/>
+              </a:spcAft>
+              <a:buSzPct val="100000"/>
+              <a:buChar char="●"/>
+            </a:pPr>
+            <a:r>
+              <a:rPr lang="en-US" sz="1600" dirty="0">
+                <a:solidFill>
+                  <a:srgbClr val="242424"/>
+                </a:solidFill>
+                <a:latin typeface="Red Hat Text" pitchFamily="34" charset="0"/>
+                <a:ea typeface="Red Hat Text" pitchFamily="34" charset="-122"/>
+                <a:cs typeface="Red Hat Text" pitchFamily="34" charset="-120"/>
+              </a:rPr>
               <a:t>Alerts on kernel truth</a:t>
+            </a:r>
+            <a:endParaRPr lang="en-US" sz="1600" dirty="0"/>
+          </a:p>
+          <a:p>
+            <a:pPr algn="l" lvl="1" indent="0" marL="0">
+              <a:lnSpc>
+                <a:spcPct val="115000"/>
+              </a:lnSpc>
+              <a:spcAft>
+                <a:spcPts val="600"/>
+              </a:spcAft>
+              <a:buNone/>
+            </a:pPr>
+            <a:r>
+              <a:rPr lang="en-US" sz="1300" dirty="0">
+                <a:solidFill>
+                  <a:srgbClr val="5A5A5A"/>
+                </a:solidFill>
+                <a:latin typeface="Red Hat Text" pitchFamily="34" charset="0"/>
+                <a:ea typeface="Red Hat Text" pitchFamily="34" charset="-122"/>
+                <a:cs typeface="Red Hat Text" pitchFamily="34" charset="-120"/>
+              </a:rPr>
+              <a:t>— 'GC pause p99 &gt; 10ms', 'ICMP drops climbing' — signals the app can't measure about itself.</a:t>
             </a:r>
             <a:endParaRPr lang="en-US" sz="1600" dirty="0"/>
           </a:p>
@@ -13972,15 +14731,15 @@
             <a:endParaRPr lang="en-US" sz="1700" dirty="0"/>
           </a:p>
           <a:p>
-            <a:pPr algn="l" lvl="1" marL="203200" indent="-101600">
+            <a:pPr algn="l" marL="342900" indent="-342900">
               <a:lnSpc>
                 <a:spcPct val="115000"/>
               </a:lnSpc>
               <a:spcAft>
-                <a:spcPts val="400"/>
+                <a:spcPts val="200"/>
               </a:spcAft>
               <a:buSzPct val="100000"/>
-              <a:buChar char="◦"/>
+              <a:buChar char="●"/>
             </a:pPr>
             <a:r>
               <a:rPr lang="en-US" sz="1700" dirty="0">
@@ -13996,26 +14755,72 @@
             <a:endParaRPr lang="en-US" sz="1700" dirty="0"/>
           </a:p>
           <a:p>
-            <a:pPr algn="l" lvl="1" marL="203200" indent="-101600">
+            <a:pPr algn="l" lvl="1" indent="0" marL="0">
               <a:lnSpc>
                 <a:spcPct val="115000"/>
               </a:lnSpc>
               <a:spcAft>
-                <a:spcPts val="400"/>
+                <a:spcPts val="600"/>
               </a:spcAft>
-              <a:buSzPct val="100000"/>
-              <a:buChar char="◦"/>
-            </a:pPr>
-            <a:r>
-              <a:rPr lang="en-US" sz="1700" dirty="0">
-                <a:solidFill>
-                  <a:srgbClr val="242424"/>
+              <a:buNone/>
+            </a:pPr>
+            <a:r>
+              <a:rPr lang="en-US" sz="1400" dirty="0">
+                <a:solidFill>
+                  <a:srgbClr val="5A5A5A"/>
                 </a:solidFill>
                 <a:latin typeface="Red Hat Text" pitchFamily="34" charset="0"/>
                 <a:ea typeface="Red Hat Text" pitchFamily="34" charset="-122"/>
                 <a:cs typeface="Red Hat Text" pitchFamily="34" charset="-120"/>
               </a:rPr>
+              <a:t>recompile with instrumentation, inject an agent, parse verbose logs, or run a sidecar.</a:t>
+            </a:r>
+            <a:endParaRPr lang="en-US" sz="1700" dirty="0"/>
+          </a:p>
+          <a:p>
+            <a:pPr algn="l" marL="342900" indent="-342900">
+              <a:lnSpc>
+                <a:spcPct val="115000"/>
+              </a:lnSpc>
+              <a:spcAft>
+                <a:spcPts val="200"/>
+              </a:spcAft>
+              <a:buSzPct val="100000"/>
+              <a:buChar char="●"/>
+            </a:pPr>
+            <a:r>
+              <a:rPr lang="en-US" sz="1700" dirty="0">
+                <a:solidFill>
+                  <a:srgbClr val="242424"/>
+                </a:solidFill>
+                <a:latin typeface="Red Hat Text" pitchFamily="34" charset="0"/>
+                <a:ea typeface="Red Hat Text" pitchFamily="34" charset="-122"/>
+                <a:cs typeface="Red Hat Text" pitchFamily="34" charset="-120"/>
+              </a:rPr>
               <a:t>eBPF is out-of-process:</a:t>
+            </a:r>
+            <a:endParaRPr lang="en-US" sz="1700" dirty="0"/>
+          </a:p>
+          <a:p>
+            <a:pPr algn="l" lvl="1" indent="0" marL="0">
+              <a:lnSpc>
+                <a:spcPct val="115000"/>
+              </a:lnSpc>
+              <a:spcAft>
+                <a:spcPts val="600"/>
+              </a:spcAft>
+              <a:buNone/>
+            </a:pPr>
+            <a:r>
+              <a:rPr lang="en-US" sz="1400" dirty="0">
+                <a:solidFill>
+                  <a:srgbClr val="5A5A5A"/>
+                </a:solidFill>
+                <a:latin typeface="Red Hat Text" pitchFamily="34" charset="0"/>
+                <a:ea typeface="Red Hat Text" pitchFamily="34" charset="-122"/>
+                <a:cs typeface="Red Hat Text" pitchFamily="34" charset="-120"/>
+              </a:rPr>
+              <a:t>the signal comes from the kernel, so the target needs no code change and no agent inside it.</a:t>
             </a:r>
             <a:endParaRPr lang="en-US" sz="1700" dirty="0"/>
           </a:p>
@@ -14909,15 +15714,15 @@
           <a:bodyPr wrap="square" rtlCol="0" anchor="t"/>
           <a:lstStyle/>
           <a:p>
-            <a:pPr algn="l" lvl="1" marL="203200" indent="-101600">
+            <a:pPr algn="l" marL="342900" indent="-342900">
               <a:lnSpc>
                 <a:spcPct val="115000"/>
               </a:lnSpc>
               <a:spcAft>
-                <a:spcPts val="400"/>
+                <a:spcPts val="200"/>
               </a:spcAft>
               <a:buSzPct val="100000"/>
-              <a:buChar char="◦"/>
+              <a:buChar char="●"/>
             </a:pPr>
             <a:r>
               <a:rPr lang="en-US" sz="1600" dirty="0">
@@ -14933,39 +15738,38 @@
             <a:endParaRPr lang="en-US" sz="1600" dirty="0"/>
           </a:p>
           <a:p>
-            <a:pPr algn="l" lvl="1" marL="203200" indent="-101600">
+            <a:pPr algn="l" lvl="1" indent="0" marL="0">
               <a:lnSpc>
                 <a:spcPct val="115000"/>
               </a:lnSpc>
               <a:spcAft>
-                <a:spcPts val="400"/>
+                <a:spcPts val="600"/>
               </a:spcAft>
-              <a:buSzPct val="100000"/>
-              <a:buChar char="◦"/>
-            </a:pPr>
-            <a:r>
-              <a:rPr lang="en-US" sz="1600" dirty="0">
-                <a:solidFill>
-                  <a:srgbClr val="242424"/>
+              <a:buNone/>
+            </a:pPr>
+            <a:r>
+              <a:rPr lang="en-US" sz="1300" dirty="0">
+                <a:solidFill>
+                  <a:srgbClr val="5A5A5A"/>
                 </a:solidFill>
                 <a:latin typeface="Red Hat Text" pitchFamily="34" charset="0"/>
                 <a:ea typeface="Red Hat Text" pitchFamily="34" charset="-122"/>
                 <a:cs typeface="Red Hat Text" pitchFamily="34" charset="-120"/>
               </a:rPr>
-              <a:t>Bounded loops only</a:t>
+              <a:t>through your program before load, tracking every register and stack slot.</a:t>
             </a:r>
             <a:endParaRPr lang="en-US" sz="1600" dirty="0"/>
           </a:p>
           <a:p>
-            <a:pPr algn="l" lvl="1" marL="203200" indent="-101600">
+            <a:pPr algn="l" marL="342900" indent="-342900">
               <a:lnSpc>
                 <a:spcPct val="115000"/>
               </a:lnSpc>
               <a:spcAft>
-                <a:spcPts val="400"/>
+                <a:spcPts val="200"/>
               </a:spcAft>
               <a:buSzPct val="100000"/>
-              <a:buChar char="◦"/>
+              <a:buChar char="●"/>
             </a:pPr>
             <a:r>
               <a:rPr lang="en-US" sz="1600" dirty="0">
@@ -14976,31 +15780,124 @@
                 <a:ea typeface="Red Hat Text" pitchFamily="34" charset="-122"/>
                 <a:cs typeface="Red Hat Text" pitchFamily="34" charset="-120"/>
               </a:rPr>
-              <a:t>Memory is checked</a:t>
+              <a:t>Bounded loops only</a:t>
             </a:r>
             <a:endParaRPr lang="en-US" sz="1600" dirty="0"/>
           </a:p>
           <a:p>
-            <a:pPr algn="l" lvl="1" marL="203200" indent="-101600">
+            <a:pPr algn="l" lvl="1" indent="0" marL="0">
               <a:lnSpc>
                 <a:spcPct val="115000"/>
               </a:lnSpc>
               <a:spcAft>
-                <a:spcPts val="400"/>
+                <a:spcPts val="600"/>
               </a:spcAft>
-              <a:buSzPct val="100000"/>
-              <a:buChar char="◦"/>
-            </a:pPr>
-            <a:r>
-              <a:rPr lang="en-US" sz="1600" dirty="0">
-                <a:solidFill>
-                  <a:srgbClr val="242424"/>
+              <a:buNone/>
+            </a:pPr>
+            <a:r>
+              <a:rPr lang="en-US" sz="1300" dirty="0">
+                <a:solidFill>
+                  <a:srgbClr val="5A5A5A"/>
                 </a:solidFill>
                 <a:latin typeface="Red Hat Text" pitchFamily="34" charset="0"/>
                 <a:ea typeface="Red Hat Text" pitchFamily="34" charset="-122"/>
                 <a:cs typeface="Red Hat Text" pitchFamily="34" charset="-120"/>
               </a:rPr>
+              <a:t>— no unbounded iteration; the program must provably terminate.</a:t>
+            </a:r>
+            <a:endParaRPr lang="en-US" sz="1600" dirty="0"/>
+          </a:p>
+          <a:p>
+            <a:pPr algn="l" marL="342900" indent="-342900">
+              <a:lnSpc>
+                <a:spcPct val="115000"/>
+              </a:lnSpc>
+              <a:spcAft>
+                <a:spcPts val="200"/>
+              </a:spcAft>
+              <a:buSzPct val="100000"/>
+              <a:buChar char="●"/>
+            </a:pPr>
+            <a:r>
+              <a:rPr lang="en-US" sz="1600" dirty="0">
+                <a:solidFill>
+                  <a:srgbClr val="242424"/>
+                </a:solidFill>
+                <a:latin typeface="Red Hat Text" pitchFamily="34" charset="0"/>
+                <a:ea typeface="Red Hat Text" pitchFamily="34" charset="-122"/>
+                <a:cs typeface="Red Hat Text" pitchFamily="34" charset="-120"/>
+              </a:rPr>
+              <a:t>Memory is checked</a:t>
+            </a:r>
+            <a:endParaRPr lang="en-US" sz="1600" dirty="0"/>
+          </a:p>
+          <a:p>
+            <a:pPr algn="l" lvl="1" indent="0" marL="0">
+              <a:lnSpc>
+                <a:spcPct val="115000"/>
+              </a:lnSpc>
+              <a:spcAft>
+                <a:spcPts val="600"/>
+              </a:spcAft>
+              <a:buNone/>
+            </a:pPr>
+            <a:r>
+              <a:rPr lang="en-US" sz="1300" dirty="0">
+                <a:solidFill>
+                  <a:srgbClr val="5A5A5A"/>
+                </a:solidFill>
+                <a:latin typeface="Red Hat Text" pitchFamily="34" charset="0"/>
+                <a:ea typeface="Red Hat Text" pitchFamily="34" charset="-122"/>
+                <a:cs typeface="Red Hat Text" pitchFamily="34" charset="-120"/>
+              </a:rPr>
+              <a:t>— every pointer access must be proven in-bounds; no wild reads or writes.</a:t>
+            </a:r>
+            <a:endParaRPr lang="en-US" sz="1600" dirty="0"/>
+          </a:p>
+          <a:p>
+            <a:pPr algn="l" marL="342900" indent="-342900">
+              <a:lnSpc>
+                <a:spcPct val="115000"/>
+              </a:lnSpc>
+              <a:spcAft>
+                <a:spcPts val="200"/>
+              </a:spcAft>
+              <a:buSzPct val="100000"/>
+              <a:buChar char="●"/>
+            </a:pPr>
+            <a:r>
+              <a:rPr lang="en-US" sz="1600" dirty="0">
+                <a:solidFill>
+                  <a:srgbClr val="242424"/>
+                </a:solidFill>
+                <a:latin typeface="Red Hat Text" pitchFamily="34" charset="0"/>
+                <a:ea typeface="Red Hat Text" pitchFamily="34" charset="-122"/>
+                <a:cs typeface="Red Hat Text" pitchFamily="34" charset="-120"/>
+              </a:rPr>
               <a:t>A finite instruction budget</a:t>
+            </a:r>
+            <a:endParaRPr lang="en-US" sz="1600" dirty="0"/>
+          </a:p>
+          <a:p>
+            <a:pPr algn="l" lvl="1" indent="0" marL="0">
+              <a:lnSpc>
+                <a:spcPct val="115000"/>
+              </a:lnSpc>
+              <a:spcAft>
+                <a:spcPts val="600"/>
+              </a:spcAft>
+              <a:buNone/>
+            </a:pPr>
+            <a:r>
+              <a:rPr lang="en-US" sz="1300" dirty="0">
+                <a:solidFill>
+                  <a:srgbClr val="5A5A5A"/>
+                </a:solidFill>
+                <a:latin typeface="Red Hat Text" pitchFamily="34" charset="0"/>
+                <a:ea typeface="Red Hat Text" pitchFamily="34" charset="-122"/>
+                <a:cs typeface="Red Hat Text" pitchFamily="34" charset="-120"/>
+              </a:rPr>
+              <a:t>— the analysis must complete, so programs have a complexity ceiling.</a:t>
             </a:r>
             <a:endParaRPr lang="en-US" sz="1600" dirty="0"/>
           </a:p>

</xml_diff>